<commit_message>
Update AXA PPTX and generator with final layout fixes
https://claude.ai/code/session_014RzVhKjh1Tf1rPzKrQUfgF
</commit_message>
<xml_diff>
--- a/UPN_Wechsel_AXA.pptx
+++ b/UPN_Wechsel_AXA.pptx
@@ -3139,8 +3139,8 @@
         </p:nvSpPr>
         <p:spPr>
           <a:xfrm>
-            <a:off x="504000" y="198000"/>
-            <a:ext cx="6660000" cy="720000"/>
+            <a:off x="521999" y="277200"/>
+            <a:ext cx="6588000" cy="295200"/>
           </a:xfrm>
           <a:prstGeom prst="rect">
             <a:avLst/>
@@ -3148,7 +3148,7 @@
           <a:noFill/>
         </p:spPr>
         <p:txBody>
-          <a:bodyPr wrap="square" lIns="45720" rIns="45720" tIns="36576" bIns="36576">
+          <a:bodyPr wrap="square" lIns="0" rIns="0" tIns="0" bIns="0">
             <a:spAutoFit/>
           </a:bodyPr>
           <a:lstStyle/>
@@ -3182,12 +3182,31 @@
               <a:t>UPN-Wechsel — Kurzanleitung</a:t>
             </a:r>
           </a:p>
-          <a:p>
-            <a:pPr algn="l">
-              <a:spcBef>
-                <a:spcPts val="300"/>
-              </a:spcBef>
-            </a:pPr>
+        </p:txBody>
+      </p:sp>
+      <p:sp>
+        <p:nvSpPr>
+          <p:cNvPr id="4" name="TextBox 3"/>
+          <p:cNvSpPr txBox="1"/>
+          <p:nvPr/>
+        </p:nvSpPr>
+        <p:spPr>
+          <a:xfrm>
+            <a:off x="521999" y="637200"/>
+            <a:ext cx="6588000" cy="234000"/>
+          </a:xfrm>
+          <a:prstGeom prst="rect">
+            <a:avLst/>
+          </a:prstGeom>
+          <a:noFill/>
+        </p:spPr>
+        <p:txBody>
+          <a:bodyPr wrap="square" lIns="0" rIns="0" tIns="0" bIns="0">
+            <a:spAutoFit/>
+          </a:bodyPr>
+          <a:lstStyle/>
+          <a:p>
+            <a:pPr algn="l"/>
             <a:r>
               <a:rPr sz="850" b="0" i="0">
                 <a:solidFill>
@@ -3202,7 +3221,7 @@
       </p:sp>
       <p:sp>
         <p:nvSpPr>
-          <p:cNvPr id="4" name="Rectangle 3"/>
+          <p:cNvPr id="5" name="Rectangle 4"/>
           <p:cNvSpPr/>
           <p:nvPr/>
         </p:nvSpPr>
@@ -3245,7 +3264,7 @@
       </p:sp>
       <p:sp>
         <p:nvSpPr>
-          <p:cNvPr id="5" name="Rectangle 4"/>
+          <p:cNvPr id="6" name="Rectangle 5"/>
           <p:cNvSpPr/>
           <p:nvPr/>
         </p:nvSpPr>
@@ -3290,13 +3309,13 @@
       </p:sp>
       <p:sp>
         <p:nvSpPr>
-          <p:cNvPr id="6" name="TextBox 5"/>
+          <p:cNvPr id="7" name="TextBox 6"/>
           <p:cNvSpPr txBox="1"/>
           <p:nvPr/>
         </p:nvSpPr>
         <p:spPr>
           <a:xfrm>
-            <a:off x="468000" y="1011600"/>
+            <a:off x="468000" y="1015200"/>
             <a:ext cx="6624000" cy="306000"/>
           </a:xfrm>
           <a:prstGeom prst="rect">
@@ -3305,12 +3324,16 @@
           <a:noFill/>
         </p:spPr>
         <p:txBody>
-          <a:bodyPr wrap="square" lIns="91440" rIns="91440" tIns="45720" bIns="45720">
+          <a:bodyPr wrap="square" lIns="36000" rIns="36000" tIns="0" bIns="0">
             <a:spAutoFit/>
           </a:bodyPr>
           <a:lstStyle/>
           <a:p>
-            <a:pPr algn="just"/>
+            <a:pPr algn="just">
+              <a:lnSpc>
+                <a:spcPct val="100000"/>
+              </a:lnSpc>
+            </a:pPr>
             <a:r>
               <a:rPr sz="850" b="0" i="0">
                 <a:solidFill>
@@ -3325,7 +3348,7 @@
       </p:sp>
       <p:sp>
         <p:nvSpPr>
-          <p:cNvPr id="7" name="Rectangle 6"/>
+          <p:cNvPr id="8" name="Rectangle 7"/>
           <p:cNvSpPr/>
           <p:nvPr/>
         </p:nvSpPr>
@@ -3368,14 +3391,14 @@
       </p:sp>
       <p:sp>
         <p:nvSpPr>
-          <p:cNvPr id="8" name="TextBox 7"/>
+          <p:cNvPr id="9" name="TextBox 8"/>
           <p:cNvSpPr txBox="1"/>
           <p:nvPr/>
         </p:nvSpPr>
         <p:spPr>
           <a:xfrm>
-            <a:off x="504000" y="1378800"/>
-            <a:ext cx="6660000" cy="208800"/>
+            <a:off x="504000" y="1407600"/>
+            <a:ext cx="6624000" cy="180000"/>
           </a:xfrm>
           <a:prstGeom prst="rect">
             <a:avLst/>
@@ -3383,7 +3406,7 @@
           <a:noFill/>
         </p:spPr>
         <p:txBody>
-          <a:bodyPr wrap="square" lIns="45720" rIns="45720" tIns="36576" bIns="36576">
+          <a:bodyPr wrap="square" lIns="0" rIns="0" tIns="0" bIns="0">
             <a:spAutoFit/>
           </a:bodyPr>
           <a:lstStyle/>
@@ -3403,14 +3426,14 @@
       </p:sp>
       <p:sp>
         <p:nvSpPr>
-          <p:cNvPr id="9" name="Rectangle 8"/>
+          <p:cNvPr id="10" name="Rectangle 9"/>
           <p:cNvSpPr/>
           <p:nvPr/>
         </p:nvSpPr>
         <p:spPr>
           <a:xfrm>
             <a:off x="396000" y="1587600"/>
-            <a:ext cx="6768000" cy="4716360"/>
+            <a:ext cx="6768000" cy="4692600"/>
           </a:xfrm>
           <a:prstGeom prst="rect">
             <a:avLst/>
@@ -3448,14 +3471,14 @@
       </p:sp>
       <p:sp>
         <p:nvSpPr>
-          <p:cNvPr id="10" name="TextBox 9"/>
+          <p:cNvPr id="11" name="TextBox 10"/>
           <p:cNvSpPr txBox="1"/>
           <p:nvPr/>
         </p:nvSpPr>
         <p:spPr>
           <a:xfrm>
-            <a:off x="450000" y="1652400"/>
-            <a:ext cx="270000" cy="901512"/>
+            <a:off x="450000" y="1666800"/>
+            <a:ext cx="259200" cy="896760"/>
           </a:xfrm>
           <a:prstGeom prst="rect">
             <a:avLst/>
@@ -3463,7 +3486,7 @@
           <a:noFill/>
         </p:spPr>
         <p:txBody>
-          <a:bodyPr wrap="none" lIns="45720" rIns="45720" tIns="36576" bIns="36576">
+          <a:bodyPr wrap="none" lIns="0" rIns="0" tIns="0" bIns="0">
             <a:spAutoFit/>
           </a:bodyPr>
           <a:lstStyle/>
@@ -3483,14 +3506,14 @@
       </p:sp>
       <p:sp>
         <p:nvSpPr>
-          <p:cNvPr id="11" name="TextBox 10"/>
+          <p:cNvPr id="12" name="TextBox 11"/>
           <p:cNvSpPr txBox="1"/>
           <p:nvPr/>
         </p:nvSpPr>
         <p:spPr>
           <a:xfrm>
-            <a:off x="774000" y="1652400"/>
-            <a:ext cx="3628800" cy="901512"/>
+            <a:off x="752400" y="1652400"/>
+            <a:ext cx="3650400" cy="896760"/>
           </a:xfrm>
           <a:prstGeom prst="rect">
             <a:avLst/>
@@ -3498,11 +3521,16 @@
           <a:noFill/>
         </p:spPr>
         <p:txBody>
-          <a:bodyPr wrap="square" lIns="45720" rIns="45720" tIns="36576" bIns="36576">
+          <a:bodyPr wrap="square" lIns="0" rIns="0" tIns="0" bIns="0">
             <a:spAutoFit/>
           </a:bodyPr>
           <a:lstStyle/>
           <a:p>
+            <a:pPr algn="l">
+              <a:spcAft>
+                <a:spcPts val="100"/>
+              </a:spcAft>
+            </a:pPr>
             <a:r>
               <a:rPr sz="850" b="1" i="0">
                 <a:solidFill>
@@ -3514,10 +3542,10 @@
             </a:r>
           </a:p>
           <a:p>
-            <a:pPr>
-              <a:spcBef>
-                <a:spcPts val="100"/>
-              </a:spcBef>
+            <a:pPr algn="l">
+              <a:lnSpc>
+                <a:spcPct val="100000"/>
+              </a:lnSpc>
             </a:pPr>
             <a:r>
               <a:rPr sz="780" b="0" i="0">
@@ -3533,365 +3561,23 @@
       </p:sp>
       <p:sp>
         <p:nvSpPr>
-          <p:cNvPr id="12" name="TextBox 11"/>
-          <p:cNvSpPr txBox="1"/>
-          <p:nvPr/>
-        </p:nvSpPr>
-        <p:spPr>
-          <a:xfrm>
-            <a:off x="450000" y="2575512"/>
-            <a:ext cx="270000" cy="901512"/>
-          </a:xfrm>
-          <a:prstGeom prst="rect">
-            <a:avLst/>
-          </a:prstGeom>
-          <a:noFill/>
-        </p:spPr>
-        <p:txBody>
-          <a:bodyPr wrap="none" lIns="45720" rIns="45720" tIns="36576" bIns="36576">
-            <a:spAutoFit/>
-          </a:bodyPr>
-          <a:lstStyle/>
-          <a:p>
-            <a:pPr algn="ctr"/>
-            <a:r>
-              <a:rPr sz="1200" b="1" i="0">
-                <a:solidFill>
-                  <a:srgbClr val="00008F"/>
-                </a:solidFill>
-                <a:latin typeface="Arial"/>
-              </a:rPr>
-              <a:t>1</a:t>
-            </a:r>
-          </a:p>
-        </p:txBody>
-      </p:sp>
-      <p:sp>
-        <p:nvSpPr>
-          <p:cNvPr id="13" name="TextBox 12"/>
-          <p:cNvSpPr txBox="1"/>
-          <p:nvPr/>
-        </p:nvSpPr>
-        <p:spPr>
-          <a:xfrm>
-            <a:off x="774000" y="2575512"/>
-            <a:ext cx="3628800" cy="901512"/>
-          </a:xfrm>
-          <a:prstGeom prst="rect">
-            <a:avLst/>
-          </a:prstGeom>
-          <a:noFill/>
-        </p:spPr>
-        <p:txBody>
-          <a:bodyPr wrap="square" lIns="45720" rIns="45720" tIns="36576" bIns="36576">
-            <a:spAutoFit/>
-          </a:bodyPr>
-          <a:lstStyle/>
-          <a:p>
-            <a:r>
-              <a:rPr sz="850" b="1" i="0">
-                <a:solidFill>
-                  <a:srgbClr val="343C3D"/>
-                </a:solidFill>
-                <a:latin typeface="Arial"/>
-              </a:rPr>
-              <a:t>Alle Notizbücher schließen</a:t>
-            </a:r>
-          </a:p>
-          <a:p>
-            <a:pPr>
-              <a:spcBef>
-                <a:spcPts val="100"/>
-              </a:spcBef>
-            </a:pPr>
-            <a:r>
-              <a:rPr sz="780" b="0" i="0">
-                <a:solidFill>
-                  <a:srgbClr val="343C3D"/>
-                </a:solidFill>
-                <a:latin typeface="Arial"/>
-              </a:rPr>
-              <a:t>Rechtsklick auf jedes Notizbuch im linken Bereich → Notizbuch schließen (Close This Notebook). Für alle wiederholen, dann App beenden.</a:t>
-            </a:r>
-          </a:p>
-        </p:txBody>
-      </p:sp>
-      <p:sp>
-        <p:nvSpPr>
-          <p:cNvPr id="14" name="TextBox 13"/>
-          <p:cNvSpPr txBox="1"/>
-          <p:nvPr/>
-        </p:nvSpPr>
-        <p:spPr>
-          <a:xfrm>
-            <a:off x="450000" y="3498624"/>
-            <a:ext cx="270000" cy="901512"/>
-          </a:xfrm>
-          <a:prstGeom prst="rect">
-            <a:avLst/>
-          </a:prstGeom>
-          <a:noFill/>
-        </p:spPr>
-        <p:txBody>
-          <a:bodyPr wrap="none" lIns="45720" rIns="45720" tIns="36576" bIns="36576">
-            <a:spAutoFit/>
-          </a:bodyPr>
-          <a:lstStyle/>
-          <a:p>
-            <a:pPr algn="ctr"/>
-            <a:r>
-              <a:rPr sz="1200" b="1" i="0">
-                <a:solidFill>
-                  <a:srgbClr val="00008F"/>
-                </a:solidFill>
-                <a:latin typeface="Arial"/>
-              </a:rPr>
-              <a:t>2</a:t>
-            </a:r>
-          </a:p>
-        </p:txBody>
-      </p:sp>
-      <p:sp>
-        <p:nvSpPr>
-          <p:cNvPr id="15" name="TextBox 14"/>
-          <p:cNvSpPr txBox="1"/>
-          <p:nvPr/>
-        </p:nvSpPr>
-        <p:spPr>
-          <a:xfrm>
-            <a:off x="774000" y="3498624"/>
-            <a:ext cx="3628800" cy="901512"/>
-          </a:xfrm>
-          <a:prstGeom prst="rect">
-            <a:avLst/>
-          </a:prstGeom>
-          <a:noFill/>
-        </p:spPr>
-        <p:txBody>
-          <a:bodyPr wrap="square" lIns="45720" rIns="45720" tIns="36576" bIns="36576">
-            <a:spAutoFit/>
-          </a:bodyPr>
-          <a:lstStyle/>
-          <a:p>
-            <a:r>
-              <a:rPr sz="850" b="1" i="0">
-                <a:solidFill>
-                  <a:srgbClr val="343C3D"/>
-                </a:solidFill>
-                <a:latin typeface="Arial"/>
-              </a:rPr>
-              <a:t>Bei OneDrive Web mit neuer Adresse anmelden</a:t>
-            </a:r>
-          </a:p>
-          <a:p>
-            <a:pPr>
-              <a:spcBef>
-                <a:spcPts val="100"/>
-              </a:spcBef>
-            </a:pPr>
-            <a:r>
-              <a:rPr sz="780" b="0" i="0">
-                <a:solidFill>
-                  <a:srgbClr val="343C3D"/>
-                </a:solidFill>
-                <a:latin typeface="Arial"/>
-              </a:rPr>
-              <a:t>Browser öffnen → onedrive.com → mit der neuen geschäftlichen E-Mail-Adresse (neuem UPN) anmelden.</a:t>
-            </a:r>
-          </a:p>
-        </p:txBody>
-      </p:sp>
-      <p:sp>
-        <p:nvSpPr>
-          <p:cNvPr id="16" name="TextBox 15"/>
-          <p:cNvSpPr txBox="1"/>
-          <p:nvPr/>
-        </p:nvSpPr>
-        <p:spPr>
-          <a:xfrm>
-            <a:off x="450000" y="4421736"/>
-            <a:ext cx="270000" cy="901512"/>
-          </a:xfrm>
-          <a:prstGeom prst="rect">
-            <a:avLst/>
-          </a:prstGeom>
-          <a:noFill/>
-        </p:spPr>
-        <p:txBody>
-          <a:bodyPr wrap="none" lIns="45720" rIns="45720" tIns="36576" bIns="36576">
-            <a:spAutoFit/>
-          </a:bodyPr>
-          <a:lstStyle/>
-          <a:p>
-            <a:pPr algn="ctr"/>
-            <a:r>
-              <a:rPr sz="1200" b="1" i="0">
-                <a:solidFill>
-                  <a:srgbClr val="00008F"/>
-                </a:solidFill>
-                <a:latin typeface="Arial"/>
-              </a:rPr>
-              <a:t>3</a:t>
-            </a:r>
-          </a:p>
-        </p:txBody>
-      </p:sp>
-      <p:sp>
-        <p:nvSpPr>
-          <p:cNvPr id="17" name="TextBox 16"/>
-          <p:cNvSpPr txBox="1"/>
-          <p:nvPr/>
-        </p:nvSpPr>
-        <p:spPr>
-          <a:xfrm>
-            <a:off x="774000" y="4421736"/>
-            <a:ext cx="3628800" cy="901512"/>
-          </a:xfrm>
-          <a:prstGeom prst="rect">
-            <a:avLst/>
-          </a:prstGeom>
-          <a:noFill/>
-        </p:spPr>
-        <p:txBody>
-          <a:bodyPr wrap="square" lIns="45720" rIns="45720" tIns="36576" bIns="36576">
-            <a:spAutoFit/>
-          </a:bodyPr>
-          <a:lstStyle/>
-          <a:p>
-            <a:r>
-              <a:rPr sz="850" b="1" i="0">
-                <a:solidFill>
-                  <a:srgbClr val="343C3D"/>
-                </a:solidFill>
-                <a:latin typeface="Arial"/>
-              </a:rPr>
-              <a:t>Notizbuch direkt aus OneDrive Web öffnen</a:t>
-            </a:r>
-          </a:p>
-          <a:p>
-            <a:pPr>
-              <a:spcBef>
-                <a:spcPts val="100"/>
-              </a:spcBef>
-            </a:pPr>
-            <a:r>
-              <a:rPr sz="780" b="0" i="0">
-                <a:solidFill>
-                  <a:srgbClr val="343C3D"/>
-                </a:solidFill>
-                <a:latin typeface="Arial"/>
-              </a:rPr>
-              <a:t>Zum Ordner des Notizbuchs navigieren und darauf klicken: öffnet sich in OneNote für das Web. (Erzwingt die Neuverknüpfung mit dem neuen UPN.)</a:t>
-            </a:r>
-          </a:p>
-        </p:txBody>
-      </p:sp>
-      <p:sp>
-        <p:nvSpPr>
-          <p:cNvPr id="18" name="TextBox 17"/>
-          <p:cNvSpPr txBox="1"/>
-          <p:nvPr/>
-        </p:nvSpPr>
-        <p:spPr>
-          <a:xfrm>
-            <a:off x="450000" y="5344848"/>
-            <a:ext cx="270000" cy="901512"/>
-          </a:xfrm>
-          <a:prstGeom prst="rect">
-            <a:avLst/>
-          </a:prstGeom>
-          <a:noFill/>
-        </p:spPr>
-        <p:txBody>
-          <a:bodyPr wrap="none" lIns="45720" rIns="45720" tIns="36576" bIns="36576">
-            <a:spAutoFit/>
-          </a:bodyPr>
-          <a:lstStyle/>
-          <a:p>
-            <a:pPr algn="ctr"/>
-            <a:r>
-              <a:rPr sz="1200" b="1" i="0">
-                <a:solidFill>
-                  <a:srgbClr val="00008F"/>
-                </a:solidFill>
-                <a:latin typeface="Arial"/>
-              </a:rPr>
-              <a:t>4</a:t>
-            </a:r>
-          </a:p>
-        </p:txBody>
-      </p:sp>
-      <p:sp>
-        <p:nvSpPr>
-          <p:cNvPr id="19" name="TextBox 18"/>
-          <p:cNvSpPr txBox="1"/>
-          <p:nvPr/>
-        </p:nvSpPr>
-        <p:spPr>
-          <a:xfrm>
-            <a:off x="774000" y="5344848"/>
-            <a:ext cx="3628800" cy="901512"/>
-          </a:xfrm>
-          <a:prstGeom prst="rect">
-            <a:avLst/>
-          </a:prstGeom>
-          <a:noFill/>
-        </p:spPr>
-        <p:txBody>
-          <a:bodyPr wrap="square" lIns="45720" rIns="45720" tIns="36576" bIns="36576">
-            <a:spAutoFit/>
-          </a:bodyPr>
-          <a:lstStyle/>
-          <a:p>
-            <a:r>
-              <a:rPr sz="850" b="1" i="0">
-                <a:solidFill>
-                  <a:srgbClr val="343C3D"/>
-                </a:solidFill>
-                <a:latin typeface="Arial"/>
-              </a:rPr>
-              <a:t>In der Desktop-App weiterarbeiten</a:t>
-            </a:r>
-          </a:p>
-          <a:p>
-            <a:pPr>
-              <a:spcBef>
-                <a:spcPts val="100"/>
-              </a:spcBef>
-            </a:pPr>
-            <a:r>
-              <a:rPr sz="780" b="0" i="0">
-                <a:solidFill>
-                  <a:srgbClr val="343C3D"/>
-                </a:solidFill>
-                <a:latin typeface="Arial"/>
-              </a:rPr>
-              <a:t>In OneNote für das Web oben rechts auf «In OneNote öffnen» klicken. Das Notizbuch ist nun korrekt mit dem neuen Konto verknüpft.</a:t>
-            </a:r>
-          </a:p>
-        </p:txBody>
-      </p:sp>
-      <p:sp>
-        <p:nvSpPr>
-          <p:cNvPr id="20" name="Rectangle 19"/>
+          <p:cNvPr id="13" name="Rectangle 12"/>
           <p:cNvSpPr/>
           <p:nvPr/>
         </p:nvSpPr>
         <p:spPr>
           <a:xfrm>
-            <a:off x="4636800" y="1605600"/>
-            <a:ext cx="2545200" cy="2588212"/>
+            <a:off x="450000" y="2561760"/>
+            <a:ext cx="3934801" cy="4320"/>
           </a:xfrm>
           <a:prstGeom prst="rect">
             <a:avLst/>
           </a:prstGeom>
           <a:solidFill>
-            <a:srgbClr val="FFFFFF"/>
+            <a:srgbClr val="BBBBE8"/>
           </a:solidFill>
-          <a:ln w="6350">
-            <a:solidFill>
-              <a:srgbClr val="BBBBE8"/>
-            </a:solidFill>
+          <a:ln>
+            <a:noFill/>
           </a:ln>
         </p:spPr>
         <p:style>
@@ -3916,40 +3602,16 @@
           </a:p>
         </p:txBody>
       </p:sp>
-      <p:pic>
-        <p:nvPicPr>
-          <p:cNvPr id="21" name="Picture 20" descr="bf765434-IMG_4052.png"/>
-          <p:cNvPicPr>
-            <a:picLocks noChangeAspect="1"/>
-          </p:cNvPicPr>
-          <p:nvPr/>
-        </p:nvPicPr>
-        <p:blipFill>
-          <a:blip r:embed="rId2"/>
-          <a:stretch>
-            <a:fillRect/>
-          </a:stretch>
-        </p:blipFill>
-        <p:spPr>
-          <a:xfrm>
-            <a:off x="4672800" y="1641600"/>
-            <a:ext cx="2473200" cy="2516212"/>
-          </a:xfrm>
-          <a:prstGeom prst="rect">
-            <a:avLst/>
-          </a:prstGeom>
-        </p:spPr>
-      </p:pic>
-      <p:sp>
-        <p:nvSpPr>
-          <p:cNvPr id="22" name="TextBox 21"/>
+      <p:sp>
+        <p:nvSpPr>
+          <p:cNvPr id="14" name="TextBox 13"/>
           <p:cNvSpPr txBox="1"/>
           <p:nvPr/>
         </p:nvSpPr>
         <p:spPr>
           <a:xfrm>
-            <a:off x="4600800" y="4186612"/>
-            <a:ext cx="2617200" cy="144000"/>
+            <a:off x="450000" y="2585160"/>
+            <a:ext cx="259200" cy="896760"/>
           </a:xfrm>
           <a:prstGeom prst="rect">
             <a:avLst/>
@@ -3957,40 +3619,95 @@
           <a:noFill/>
         </p:spPr>
         <p:txBody>
-          <a:bodyPr wrap="square" lIns="45720" rIns="45720" tIns="36576" bIns="36576">
+          <a:bodyPr wrap="none" lIns="0" rIns="0" tIns="0" bIns="0">
             <a:spAutoFit/>
           </a:bodyPr>
           <a:lstStyle/>
           <a:p>
             <a:pPr algn="ctr"/>
             <a:r>
-              <a:rPr sz="750" b="0" i="1">
-                <a:solidFill>
-                  <a:srgbClr val="8C9BA5"/>
+              <a:rPr sz="1200" b="1" i="0">
+                <a:solidFill>
+                  <a:srgbClr val="00008F"/>
                 </a:solidFill>
                 <a:latin typeface="Arial"/>
               </a:rPr>
-              <a:t>Rechtsklick → Notizbuch schließen</a:t>
-            </a:r>
-          </a:p>
-        </p:txBody>
-      </p:sp>
-      <p:sp>
-        <p:nvSpPr>
-          <p:cNvPr id="23" name="Rectangle 22"/>
+              <a:t>1</a:t>
+            </a:r>
+          </a:p>
+        </p:txBody>
+      </p:sp>
+      <p:sp>
+        <p:nvSpPr>
+          <p:cNvPr id="15" name="TextBox 14"/>
+          <p:cNvSpPr txBox="1"/>
+          <p:nvPr/>
+        </p:nvSpPr>
+        <p:spPr>
+          <a:xfrm>
+            <a:off x="752400" y="2570760"/>
+            <a:ext cx="3650400" cy="896760"/>
+          </a:xfrm>
+          <a:prstGeom prst="rect">
+            <a:avLst/>
+          </a:prstGeom>
+          <a:noFill/>
+        </p:spPr>
+        <p:txBody>
+          <a:bodyPr wrap="square" lIns="0" rIns="0" tIns="0" bIns="0">
+            <a:spAutoFit/>
+          </a:bodyPr>
+          <a:lstStyle/>
+          <a:p>
+            <a:pPr algn="l">
+              <a:spcAft>
+                <a:spcPts val="100"/>
+              </a:spcAft>
+            </a:pPr>
+            <a:r>
+              <a:rPr sz="850" b="1" i="0">
+                <a:solidFill>
+                  <a:srgbClr val="343C3D"/>
+                </a:solidFill>
+                <a:latin typeface="Arial"/>
+              </a:rPr>
+              <a:t>Alle Notizbücher schließen</a:t>
+            </a:r>
+          </a:p>
+          <a:p>
+            <a:pPr algn="l">
+              <a:lnSpc>
+                <a:spcPct val="100000"/>
+              </a:lnSpc>
+            </a:pPr>
+            <a:r>
+              <a:rPr sz="780" b="0" i="0">
+                <a:solidFill>
+                  <a:srgbClr val="343C3D"/>
+                </a:solidFill>
+                <a:latin typeface="Arial"/>
+              </a:rPr>
+              <a:t>Rechtsklick auf jedes Notizbuch im linken Bereich → Notizbuch schließen (Close This Notebook). Für alle wiederholen, dann App beenden.</a:t>
+            </a:r>
+          </a:p>
+        </p:txBody>
+      </p:sp>
+      <p:sp>
+        <p:nvSpPr>
+          <p:cNvPr id="16" name="Rectangle 15"/>
           <p:cNvSpPr/>
           <p:nvPr/>
         </p:nvSpPr>
         <p:spPr>
           <a:xfrm>
-            <a:off x="396000" y="6347160"/>
-            <a:ext cx="6768000" cy="208800"/>
+            <a:off x="450000" y="3480120"/>
+            <a:ext cx="3934801" cy="4320"/>
           </a:xfrm>
           <a:prstGeom prst="rect">
             <a:avLst/>
           </a:prstGeom>
           <a:solidFill>
-            <a:srgbClr val="00008F"/>
+            <a:srgbClr val="BBBBE8"/>
           </a:solidFill>
           <a:ln>
             <a:noFill/>
@@ -4020,14 +3737,14 @@
       </p:sp>
       <p:sp>
         <p:nvSpPr>
-          <p:cNvPr id="24" name="TextBox 23"/>
+          <p:cNvPr id="17" name="TextBox 16"/>
           <p:cNvSpPr txBox="1"/>
           <p:nvPr/>
         </p:nvSpPr>
         <p:spPr>
           <a:xfrm>
-            <a:off x="504000" y="6347160"/>
-            <a:ext cx="6660000" cy="208800"/>
+            <a:off x="450000" y="3503520"/>
+            <a:ext cx="259200" cy="896760"/>
           </a:xfrm>
           <a:prstGeom prst="rect">
             <a:avLst/>
@@ -4035,45 +3752,98 @@
           <a:noFill/>
         </p:spPr>
         <p:txBody>
-          <a:bodyPr wrap="square" lIns="45720" rIns="45720" tIns="36576" bIns="36576">
+          <a:bodyPr wrap="none" lIns="0" rIns="0" tIns="0" bIns="0">
             <a:spAutoFit/>
           </a:bodyPr>
           <a:lstStyle/>
           <a:p>
-            <a:pPr algn="l"/>
-            <a:r>
-              <a:rPr sz="1050" b="1" i="0">
-                <a:solidFill>
-                  <a:srgbClr val="FFFFFF"/>
+            <a:pPr algn="ctr"/>
+            <a:r>
+              <a:rPr sz="1200" b="1" i="0">
+                <a:solidFill>
+                  <a:srgbClr val="00008F"/>
                 </a:solidFill>
                 <a:latin typeface="Arial"/>
               </a:rPr>
-              <a:t>2 — OneDrive — Freigaben neu erstellen</a:t>
-            </a:r>
-          </a:p>
-        </p:txBody>
-      </p:sp>
-      <p:sp>
-        <p:nvSpPr>
-          <p:cNvPr id="25" name="Rectangle 24"/>
+              <a:t>2</a:t>
+            </a:r>
+          </a:p>
+        </p:txBody>
+      </p:sp>
+      <p:sp>
+        <p:nvSpPr>
+          <p:cNvPr id="18" name="TextBox 17"/>
+          <p:cNvSpPr txBox="1"/>
+          <p:nvPr/>
+        </p:nvSpPr>
+        <p:spPr>
+          <a:xfrm>
+            <a:off x="752400" y="3489120"/>
+            <a:ext cx="3650400" cy="896760"/>
+          </a:xfrm>
+          <a:prstGeom prst="rect">
+            <a:avLst/>
+          </a:prstGeom>
+          <a:noFill/>
+        </p:spPr>
+        <p:txBody>
+          <a:bodyPr wrap="square" lIns="0" rIns="0" tIns="0" bIns="0">
+            <a:spAutoFit/>
+          </a:bodyPr>
+          <a:lstStyle/>
+          <a:p>
+            <a:pPr algn="l">
+              <a:spcAft>
+                <a:spcPts val="100"/>
+              </a:spcAft>
+            </a:pPr>
+            <a:r>
+              <a:rPr sz="850" b="1" i="0">
+                <a:solidFill>
+                  <a:srgbClr val="343C3D"/>
+                </a:solidFill>
+                <a:latin typeface="Arial"/>
+              </a:rPr>
+              <a:t>Bei OneDrive Web mit neuer Adresse anmelden</a:t>
+            </a:r>
+          </a:p>
+          <a:p>
+            <a:pPr algn="l">
+              <a:lnSpc>
+                <a:spcPct val="100000"/>
+              </a:lnSpc>
+            </a:pPr>
+            <a:r>
+              <a:rPr sz="780" b="0" i="0">
+                <a:solidFill>
+                  <a:srgbClr val="343C3D"/>
+                </a:solidFill>
+                <a:latin typeface="Arial"/>
+              </a:rPr>
+              <a:t>Browser öffnen → onedrive.com → mit der neuen geschäftlichen E-Mail-Adresse (neuem UPN) anmelden.</a:t>
+            </a:r>
+          </a:p>
+        </p:txBody>
+      </p:sp>
+      <p:sp>
+        <p:nvSpPr>
+          <p:cNvPr id="19" name="Rectangle 18"/>
           <p:cNvSpPr/>
           <p:nvPr/>
         </p:nvSpPr>
         <p:spPr>
           <a:xfrm>
-            <a:off x="396000" y="6555960"/>
-            <a:ext cx="6768000" cy="3815640"/>
+            <a:off x="450000" y="4398480"/>
+            <a:ext cx="3934801" cy="4320"/>
           </a:xfrm>
           <a:prstGeom prst="rect">
             <a:avLst/>
           </a:prstGeom>
           <a:solidFill>
-            <a:srgbClr val="EEEEF8"/>
+            <a:srgbClr val="BBBBE8"/>
           </a:solidFill>
-          <a:ln w="7620">
-            <a:solidFill>
-              <a:srgbClr val="BBBBE8"/>
-            </a:solidFill>
+          <a:ln>
+            <a:noFill/>
           </a:ln>
         </p:spPr>
         <p:style>
@@ -4100,20 +3870,110 @@
       </p:sp>
       <p:sp>
         <p:nvSpPr>
-          <p:cNvPr id="26" name="Rectangle 25"/>
+          <p:cNvPr id="20" name="TextBox 19"/>
+          <p:cNvSpPr txBox="1"/>
+          <p:nvPr/>
+        </p:nvSpPr>
+        <p:spPr>
+          <a:xfrm>
+            <a:off x="450000" y="4421880"/>
+            <a:ext cx="259200" cy="896760"/>
+          </a:xfrm>
+          <a:prstGeom prst="rect">
+            <a:avLst/>
+          </a:prstGeom>
+          <a:noFill/>
+        </p:spPr>
+        <p:txBody>
+          <a:bodyPr wrap="none" lIns="0" rIns="0" tIns="0" bIns="0">
+            <a:spAutoFit/>
+          </a:bodyPr>
+          <a:lstStyle/>
+          <a:p>
+            <a:pPr algn="ctr"/>
+            <a:r>
+              <a:rPr sz="1200" b="1" i="0">
+                <a:solidFill>
+                  <a:srgbClr val="00008F"/>
+                </a:solidFill>
+                <a:latin typeface="Arial"/>
+              </a:rPr>
+              <a:t>3</a:t>
+            </a:r>
+          </a:p>
+        </p:txBody>
+      </p:sp>
+      <p:sp>
+        <p:nvSpPr>
+          <p:cNvPr id="21" name="TextBox 20"/>
+          <p:cNvSpPr txBox="1"/>
+          <p:nvPr/>
+        </p:nvSpPr>
+        <p:spPr>
+          <a:xfrm>
+            <a:off x="752400" y="4407480"/>
+            <a:ext cx="3650400" cy="896760"/>
+          </a:xfrm>
+          <a:prstGeom prst="rect">
+            <a:avLst/>
+          </a:prstGeom>
+          <a:noFill/>
+        </p:spPr>
+        <p:txBody>
+          <a:bodyPr wrap="square" lIns="0" rIns="0" tIns="0" bIns="0">
+            <a:spAutoFit/>
+          </a:bodyPr>
+          <a:lstStyle/>
+          <a:p>
+            <a:pPr algn="l">
+              <a:spcAft>
+                <a:spcPts val="100"/>
+              </a:spcAft>
+            </a:pPr>
+            <a:r>
+              <a:rPr sz="850" b="1" i="0">
+                <a:solidFill>
+                  <a:srgbClr val="343C3D"/>
+                </a:solidFill>
+                <a:latin typeface="Arial"/>
+              </a:rPr>
+              <a:t>Notizbuch direkt aus OneDrive Web öffnen</a:t>
+            </a:r>
+          </a:p>
+          <a:p>
+            <a:pPr algn="l">
+              <a:lnSpc>
+                <a:spcPct val="100000"/>
+              </a:lnSpc>
+            </a:pPr>
+            <a:r>
+              <a:rPr sz="780" b="0" i="0">
+                <a:solidFill>
+                  <a:srgbClr val="343C3D"/>
+                </a:solidFill>
+                <a:latin typeface="Arial"/>
+              </a:rPr>
+              <a:t>Zum Ordner des Notizbuchs navigieren und darauf klicken: öffnet sich in OneNote für das Web. (Erzwingt die Neuverknüpfung mit dem neuen UPN.)</a:t>
+            </a:r>
+          </a:p>
+        </p:txBody>
+      </p:sp>
+      <p:sp>
+        <p:nvSpPr>
+          <p:cNvPr id="22" name="Rectangle 21"/>
           <p:cNvSpPr/>
           <p:nvPr/>
         </p:nvSpPr>
         <p:spPr>
           <a:xfrm>
-            <a:off x="450000" y="6599160"/>
-            <a:ext cx="6660000" cy="342000"/>
+            <a:off x="450000" y="5316840"/>
+            <a:ext cx="3934801" cy="4320"/>
           </a:xfrm>
           <a:prstGeom prst="rect">
             <a:avLst/>
           </a:prstGeom>
           <a:solidFill>
-            <a:srgbClr val="FFF0F0"/>
+            <a:srgbClr val="BBBBE8"/>
           </a:solidFill>
           <a:ln>
             <a:noFill/>
@@ -4143,23 +4003,115 @@
       </p:sp>
       <p:sp>
         <p:nvSpPr>
-          <p:cNvPr id="27" name="Rectangle 26"/>
+          <p:cNvPr id="23" name="TextBox 22"/>
+          <p:cNvSpPr txBox="1"/>
+          <p:nvPr/>
+        </p:nvSpPr>
+        <p:spPr>
+          <a:xfrm>
+            <a:off x="450000" y="5340240"/>
+            <a:ext cx="259200" cy="896760"/>
+          </a:xfrm>
+          <a:prstGeom prst="rect">
+            <a:avLst/>
+          </a:prstGeom>
+          <a:noFill/>
+        </p:spPr>
+        <p:txBody>
+          <a:bodyPr wrap="none" lIns="0" rIns="0" tIns="0" bIns="0">
+            <a:spAutoFit/>
+          </a:bodyPr>
+          <a:lstStyle/>
+          <a:p>
+            <a:pPr algn="ctr"/>
+            <a:r>
+              <a:rPr sz="1200" b="1" i="0">
+                <a:solidFill>
+                  <a:srgbClr val="00008F"/>
+                </a:solidFill>
+                <a:latin typeface="Arial"/>
+              </a:rPr>
+              <a:t>4</a:t>
+            </a:r>
+          </a:p>
+        </p:txBody>
+      </p:sp>
+      <p:sp>
+        <p:nvSpPr>
+          <p:cNvPr id="24" name="TextBox 23"/>
+          <p:cNvSpPr txBox="1"/>
+          <p:nvPr/>
+        </p:nvSpPr>
+        <p:spPr>
+          <a:xfrm>
+            <a:off x="752400" y="5325840"/>
+            <a:ext cx="3650400" cy="896760"/>
+          </a:xfrm>
+          <a:prstGeom prst="rect">
+            <a:avLst/>
+          </a:prstGeom>
+          <a:noFill/>
+        </p:spPr>
+        <p:txBody>
+          <a:bodyPr wrap="square" lIns="0" rIns="0" tIns="0" bIns="0">
+            <a:spAutoFit/>
+          </a:bodyPr>
+          <a:lstStyle/>
+          <a:p>
+            <a:pPr algn="l">
+              <a:spcAft>
+                <a:spcPts val="100"/>
+              </a:spcAft>
+            </a:pPr>
+            <a:r>
+              <a:rPr sz="850" b="1" i="0">
+                <a:solidFill>
+                  <a:srgbClr val="343C3D"/>
+                </a:solidFill>
+                <a:latin typeface="Arial"/>
+              </a:rPr>
+              <a:t>In der Desktop-App weiterarbeiten</a:t>
+            </a:r>
+          </a:p>
+          <a:p>
+            <a:pPr algn="l">
+              <a:lnSpc>
+                <a:spcPct val="100000"/>
+              </a:lnSpc>
+            </a:pPr>
+            <a:r>
+              <a:rPr sz="780" b="0" i="0">
+                <a:solidFill>
+                  <a:srgbClr val="343C3D"/>
+                </a:solidFill>
+                <a:latin typeface="Arial"/>
+              </a:rPr>
+              <a:t>In OneNote für das Web oben rechts auf «In OneNote öffnen» klicken. Das Notizbuch ist nun korrekt mit dem neuen Konto verknüpft.</a:t>
+            </a:r>
+          </a:p>
+        </p:txBody>
+      </p:sp>
+      <p:sp>
+        <p:nvSpPr>
+          <p:cNvPr id="25" name="Rectangle 24"/>
           <p:cNvSpPr/>
           <p:nvPr/>
         </p:nvSpPr>
         <p:spPr>
           <a:xfrm>
-            <a:off x="450000" y="6599160"/>
-            <a:ext cx="64800" cy="342000"/>
+            <a:off x="4555799" y="1616400"/>
+            <a:ext cx="2581201" cy="2624839"/>
           </a:xfrm>
           <a:prstGeom prst="rect">
             <a:avLst/>
           </a:prstGeom>
           <a:solidFill>
-            <a:srgbClr val="FF1721"/>
+            <a:srgbClr val="FFFFFF"/>
           </a:solidFill>
-          <a:ln>
-            <a:noFill/>
+          <a:ln w="6350">
+            <a:solidFill>
+              <a:srgbClr val="BBBBE8"/>
+            </a:solidFill>
           </a:ln>
         </p:spPr>
         <p:style>
@@ -4184,16 +4136,40 @@
           </a:p>
         </p:txBody>
       </p:sp>
-      <p:sp>
-        <p:nvSpPr>
-          <p:cNvPr id="28" name="TextBox 27"/>
+      <p:pic>
+        <p:nvPicPr>
+          <p:cNvPr id="26" name="Picture 25" descr="bf765434-IMG_4052.png"/>
+          <p:cNvPicPr>
+            <a:picLocks noChangeAspect="1"/>
+          </p:cNvPicPr>
+          <p:nvPr/>
+        </p:nvPicPr>
+        <p:blipFill>
+          <a:blip r:embed="rId2"/>
+          <a:stretch>
+            <a:fillRect/>
+          </a:stretch>
+        </p:blipFill>
+        <p:spPr>
+          <a:xfrm>
+            <a:off x="4591799" y="1652400"/>
+            <a:ext cx="2509201" cy="2552839"/>
+          </a:xfrm>
+          <a:prstGeom prst="rect">
+            <a:avLst/>
+          </a:prstGeom>
+        </p:spPr>
+      </p:pic>
+      <p:sp>
+        <p:nvSpPr>
+          <p:cNvPr id="27" name="TextBox 26"/>
           <p:cNvSpPr txBox="1"/>
           <p:nvPr/>
         </p:nvSpPr>
         <p:spPr>
           <a:xfrm>
-            <a:off x="558000" y="6620760"/>
-            <a:ext cx="6534000" cy="298800"/>
+            <a:off x="4528800" y="4262839"/>
+            <a:ext cx="2635200" cy="144000"/>
           </a:xfrm>
           <a:prstGeom prst="rect">
             <a:avLst/>
@@ -4201,322 +4177,40 @@
           <a:noFill/>
         </p:spPr>
         <p:txBody>
-          <a:bodyPr wrap="square" lIns="91440" rIns="91440" tIns="45720" bIns="45720">
+          <a:bodyPr wrap="square" lIns="0" rIns="0" tIns="0" bIns="0">
             <a:spAutoFit/>
           </a:bodyPr>
           <a:lstStyle/>
           <a:p>
-            <a:pPr algn="l"/>
-            <a:r>
-              <a:rPr sz="850" b="1" i="0">
-                <a:solidFill>
-                  <a:srgbClr val="FF1721"/>
+            <a:pPr algn="ctr"/>
+            <a:r>
+              <a:rPr sz="750" b="0" i="1">
+                <a:solidFill>
+                  <a:srgbClr val="8C9BA5"/>
                 </a:solidFill>
                 <a:latin typeface="Arial"/>
               </a:rPr>
-              <a:t>⚠  </a:t>
-            </a:r>
-            <a:r>
-              <a:rPr sz="850" b="0" i="0">
-                <a:solidFill>
-                  <a:srgbClr val="8F0000"/>
-                </a:solidFill>
-                <a:latin typeface="Arial"/>
-              </a:rPr>
-              <a:t>Alle Freigaben mit dem alten UPN werden </a:t>
-            </a:r>
-            <a:r>
-              <a:rPr sz="850" b="1" i="0">
-                <a:solidFill>
-                  <a:srgbClr val="8F0000"/>
-                </a:solidFill>
-                <a:latin typeface="Arial"/>
-              </a:rPr>
-              <a:t>automatisch ungültig.</a:t>
-            </a:r>
-            <a:r>
-              <a:rPr sz="850" b="0" i="0">
-                <a:solidFill>
-                  <a:srgbClr val="8F0000"/>
-                </a:solidFill>
-                <a:latin typeface="Arial"/>
-              </a:rPr>
-              <a:t> Empfänger verlieren den Zugriff — jedes Element muss manuell neu geteilt werden.</a:t>
-            </a:r>
-          </a:p>
-        </p:txBody>
-      </p:sp>
-      <p:sp>
-        <p:nvSpPr>
-          <p:cNvPr id="29" name="TextBox 28"/>
-          <p:cNvSpPr txBox="1"/>
-          <p:nvPr/>
-        </p:nvSpPr>
-        <p:spPr>
-          <a:xfrm>
-            <a:off x="450000" y="6984360"/>
-            <a:ext cx="270000" cy="1096680"/>
-          </a:xfrm>
-          <a:prstGeom prst="rect">
-            <a:avLst/>
-          </a:prstGeom>
-          <a:noFill/>
-        </p:spPr>
-        <p:txBody>
-          <a:bodyPr wrap="none" lIns="45720" rIns="45720" tIns="36576" bIns="36576">
-            <a:spAutoFit/>
-          </a:bodyPr>
-          <a:lstStyle/>
-          <a:p>
-            <a:pPr algn="ctr"/>
-            <a:r>
-              <a:rPr sz="1200" b="1" i="0">
-                <a:solidFill>
-                  <a:srgbClr val="00008F"/>
-                </a:solidFill>
-                <a:latin typeface="Arial"/>
-              </a:rPr>
-              <a:t>1</a:t>
-            </a:r>
-          </a:p>
-        </p:txBody>
-      </p:sp>
-      <p:sp>
-        <p:nvSpPr>
-          <p:cNvPr id="30" name="TextBox 29"/>
-          <p:cNvSpPr txBox="1"/>
-          <p:nvPr/>
-        </p:nvSpPr>
-        <p:spPr>
-          <a:xfrm>
-            <a:off x="774000" y="6984360"/>
-            <a:ext cx="6336000" cy="1096680"/>
-          </a:xfrm>
-          <a:prstGeom prst="rect">
-            <a:avLst/>
-          </a:prstGeom>
-          <a:noFill/>
-        </p:spPr>
-        <p:txBody>
-          <a:bodyPr wrap="square" lIns="45720" rIns="45720" tIns="36576" bIns="36576">
-            <a:spAutoFit/>
-          </a:bodyPr>
-          <a:lstStyle/>
-          <a:p>
-            <a:r>
-              <a:rPr sz="850" b="1" i="0">
-                <a:solidFill>
-                  <a:srgbClr val="343C3D"/>
-                </a:solidFill>
-                <a:latin typeface="Arial"/>
-              </a:rPr>
-              <a:t>Freigegebene Elemente finden</a:t>
-            </a:r>
-          </a:p>
-          <a:p>
-            <a:pPr>
-              <a:spcBef>
-                <a:spcPts val="100"/>
-              </a:spcBef>
-            </a:pPr>
-            <a:r>
-              <a:rPr sz="780" b="0" i="0">
-                <a:solidFill>
-                  <a:srgbClr val="343C3D"/>
-                </a:solidFill>
-                <a:latin typeface="Arial"/>
-              </a:rPr>
-              <a:t>Bei onedrive.com mit neuer Adresse anmelden → im linken Bereich auf «Geteilt» klicken → alle früheren Freigaben werden angezeigt.</a:t>
-            </a:r>
-          </a:p>
-        </p:txBody>
-      </p:sp>
-      <p:sp>
-        <p:nvSpPr>
-          <p:cNvPr id="31" name="TextBox 30"/>
-          <p:cNvSpPr txBox="1"/>
-          <p:nvPr/>
-        </p:nvSpPr>
-        <p:spPr>
-          <a:xfrm>
-            <a:off x="450000" y="8099040"/>
-            <a:ext cx="270000" cy="1096680"/>
-          </a:xfrm>
-          <a:prstGeom prst="rect">
-            <a:avLst/>
-          </a:prstGeom>
-          <a:noFill/>
-        </p:spPr>
-        <p:txBody>
-          <a:bodyPr wrap="none" lIns="45720" rIns="45720" tIns="36576" bIns="36576">
-            <a:spAutoFit/>
-          </a:bodyPr>
-          <a:lstStyle/>
-          <a:p>
-            <a:pPr algn="ctr"/>
-            <a:r>
-              <a:rPr sz="1200" b="1" i="0">
-                <a:solidFill>
-                  <a:srgbClr val="00008F"/>
-                </a:solidFill>
-                <a:latin typeface="Arial"/>
-              </a:rPr>
-              <a:t>2</a:t>
-            </a:r>
-          </a:p>
-        </p:txBody>
-      </p:sp>
-      <p:sp>
-        <p:nvSpPr>
-          <p:cNvPr id="32" name="TextBox 31"/>
-          <p:cNvSpPr txBox="1"/>
-          <p:nvPr/>
-        </p:nvSpPr>
-        <p:spPr>
-          <a:xfrm>
-            <a:off x="774000" y="8099040"/>
-            <a:ext cx="6336000" cy="1096680"/>
-          </a:xfrm>
-          <a:prstGeom prst="rect">
-            <a:avLst/>
-          </a:prstGeom>
-          <a:noFill/>
-        </p:spPr>
-        <p:txBody>
-          <a:bodyPr wrap="square" lIns="45720" rIns="45720" tIns="36576" bIns="36576">
-            <a:spAutoFit/>
-          </a:bodyPr>
-          <a:lstStyle/>
-          <a:p>
-            <a:r>
-              <a:rPr sz="850" b="1" i="0">
-                <a:solidFill>
-                  <a:srgbClr val="343C3D"/>
-                </a:solidFill>
-                <a:latin typeface="Arial"/>
-              </a:rPr>
-              <a:t>Jede Datei / jeden Ordner neu freigeben</a:t>
-            </a:r>
-          </a:p>
-          <a:p>
-            <a:pPr>
-              <a:spcBef>
-                <a:spcPts val="100"/>
-              </a:spcBef>
-            </a:pPr>
-            <a:r>
-              <a:rPr sz="780" b="0" i="0">
-                <a:solidFill>
-                  <a:srgbClr val="343C3D"/>
-                </a:solidFill>
-                <a:latin typeface="Arial"/>
-              </a:rPr>
-              <a:t>Rechtsklick → Freigeben → Empfänger eingeben → Berechtigung wählen (Anzeigen / Bearbeiten) → Senden.</a:t>
-            </a:r>
-          </a:p>
-        </p:txBody>
-      </p:sp>
-      <p:sp>
-        <p:nvSpPr>
-          <p:cNvPr id="33" name="TextBox 32"/>
-          <p:cNvSpPr txBox="1"/>
-          <p:nvPr/>
-        </p:nvSpPr>
-        <p:spPr>
-          <a:xfrm>
-            <a:off x="450000" y="9213720"/>
-            <a:ext cx="270000" cy="1096680"/>
-          </a:xfrm>
-          <a:prstGeom prst="rect">
-            <a:avLst/>
-          </a:prstGeom>
-          <a:noFill/>
-        </p:spPr>
-        <p:txBody>
-          <a:bodyPr wrap="none" lIns="45720" rIns="45720" tIns="36576" bIns="36576">
-            <a:spAutoFit/>
-          </a:bodyPr>
-          <a:lstStyle/>
-          <a:p>
-            <a:pPr algn="ctr"/>
-            <a:r>
-              <a:rPr sz="1200" b="1" i="0">
-                <a:solidFill>
-                  <a:srgbClr val="00008F"/>
-                </a:solidFill>
-                <a:latin typeface="Arial"/>
-              </a:rPr>
-              <a:t>3</a:t>
-            </a:r>
-          </a:p>
-        </p:txBody>
-      </p:sp>
-      <p:sp>
-        <p:nvSpPr>
-          <p:cNvPr id="34" name="TextBox 33"/>
-          <p:cNvSpPr txBox="1"/>
-          <p:nvPr/>
-        </p:nvSpPr>
-        <p:spPr>
-          <a:xfrm>
-            <a:off x="774000" y="9213720"/>
-            <a:ext cx="6336000" cy="1096680"/>
-          </a:xfrm>
-          <a:prstGeom prst="rect">
-            <a:avLst/>
-          </a:prstGeom>
-          <a:noFill/>
-        </p:spPr>
-        <p:txBody>
-          <a:bodyPr wrap="square" lIns="45720" rIns="45720" tIns="36576" bIns="36576">
-            <a:spAutoFit/>
-          </a:bodyPr>
-          <a:lstStyle/>
-          <a:p>
-            <a:r>
-              <a:rPr sz="850" b="1" i="0">
-                <a:solidFill>
-                  <a:srgbClr val="343C3D"/>
-                </a:solidFill>
-                <a:latin typeface="Arial"/>
-              </a:rPr>
-              <a:t>Empfänger über neuen Link informieren</a:t>
-            </a:r>
-          </a:p>
-          <a:p>
-            <a:pPr>
-              <a:spcBef>
-                <a:spcPts val="100"/>
-              </a:spcBef>
-            </a:pPr>
-            <a:r>
-              <a:rPr sz="780" b="0" i="0">
-                <a:solidFill>
-                  <a:srgbClr val="343C3D"/>
-                </a:solidFill>
-                <a:latin typeface="Arial"/>
-              </a:rPr>
-              <a:t>Alte Links funktionieren nicht mehr. Neue Einladung versenden oder Link direkt mitteilen. Für SharePoint-Bibliotheken das IT-Team kontaktieren.</a:t>
-            </a:r>
-          </a:p>
-        </p:txBody>
-      </p:sp>
-      <p:sp>
-        <p:nvSpPr>
-          <p:cNvPr id="35" name="Rectangle 34"/>
+              <a:t>Rechtsklick → Notizbuch schließen</a:t>
+            </a:r>
+          </a:p>
+        </p:txBody>
+      </p:sp>
+      <p:sp>
+        <p:nvSpPr>
+          <p:cNvPr id="28" name="Rectangle 27"/>
           <p:cNvSpPr/>
           <p:nvPr/>
         </p:nvSpPr>
         <p:spPr>
           <a:xfrm>
-            <a:off x="396000" y="10414800"/>
-            <a:ext cx="6768000" cy="10800"/>
+            <a:off x="396000" y="6323400"/>
+            <a:ext cx="6768000" cy="208800"/>
           </a:xfrm>
           <a:prstGeom prst="rect">
             <a:avLst/>
           </a:prstGeom>
           <a:solidFill>
-            <a:srgbClr val="CCCCCC"/>
+            <a:srgbClr val="00008F"/>
           </a:solidFill>
           <a:ln>
             <a:noFill/>
@@ -4546,14 +4240,14 @@
       </p:sp>
       <p:sp>
         <p:nvSpPr>
-          <p:cNvPr id="36" name="TextBox 35"/>
+          <p:cNvPr id="29" name="TextBox 28"/>
           <p:cNvSpPr txBox="1"/>
           <p:nvPr/>
         </p:nvSpPr>
         <p:spPr>
           <a:xfrm>
-            <a:off x="396000" y="10432800"/>
-            <a:ext cx="6768000" cy="216000"/>
+            <a:off x="504000" y="6352200"/>
+            <a:ext cx="6624000" cy="180000"/>
           </a:xfrm>
           <a:prstGeom prst="rect">
             <a:avLst/>
@@ -4561,7 +4255,638 @@
           <a:noFill/>
         </p:spPr>
         <p:txBody>
-          <a:bodyPr wrap="square" lIns="45720" rIns="45720" tIns="36576" bIns="36576">
+          <a:bodyPr wrap="square" lIns="0" rIns="0" tIns="0" bIns="0">
+            <a:spAutoFit/>
+          </a:bodyPr>
+          <a:lstStyle/>
+          <a:p>
+            <a:pPr algn="l"/>
+            <a:r>
+              <a:rPr sz="1050" b="1" i="0">
+                <a:solidFill>
+                  <a:srgbClr val="FFFFFF"/>
+                </a:solidFill>
+                <a:latin typeface="Arial"/>
+              </a:rPr>
+              <a:t>2 — OneDrive — Freigaben neu erstellen</a:t>
+            </a:r>
+          </a:p>
+        </p:txBody>
+      </p:sp>
+      <p:sp>
+        <p:nvSpPr>
+          <p:cNvPr id="30" name="Rectangle 29"/>
+          <p:cNvSpPr/>
+          <p:nvPr/>
+        </p:nvSpPr>
+        <p:spPr>
+          <a:xfrm>
+            <a:off x="396000" y="6532200"/>
+            <a:ext cx="6768000" cy="3796200"/>
+          </a:xfrm>
+          <a:prstGeom prst="rect">
+            <a:avLst/>
+          </a:prstGeom>
+          <a:solidFill>
+            <a:srgbClr val="EEEEF8"/>
+          </a:solidFill>
+          <a:ln w="7620">
+            <a:solidFill>
+              <a:srgbClr val="BBBBE8"/>
+            </a:solidFill>
+          </a:ln>
+        </p:spPr>
+        <p:style>
+          <a:lnRef idx="1">
+            <a:schemeClr val="accent1"/>
+          </a:lnRef>
+          <a:fillRef idx="3">
+            <a:schemeClr val="accent1"/>
+          </a:fillRef>
+          <a:effectRef idx="2">
+            <a:schemeClr val="accent1"/>
+          </a:effectRef>
+          <a:fontRef idx="minor">
+            <a:schemeClr val="lt1"/>
+          </a:fontRef>
+        </p:style>
+        <p:txBody>
+          <a:bodyPr rtlCol="0" anchor="ctr"/>
+          <a:lstStyle/>
+          <a:p>
+            <a:pPr algn="ctr"/>
+          </a:p>
+        </p:txBody>
+      </p:sp>
+      <p:sp>
+        <p:nvSpPr>
+          <p:cNvPr id="31" name="Rectangle 30"/>
+          <p:cNvSpPr/>
+          <p:nvPr/>
+        </p:nvSpPr>
+        <p:spPr>
+          <a:xfrm>
+            <a:off x="450000" y="6575400"/>
+            <a:ext cx="6660000" cy="342000"/>
+          </a:xfrm>
+          <a:prstGeom prst="rect">
+            <a:avLst/>
+          </a:prstGeom>
+          <a:solidFill>
+            <a:srgbClr val="FFF0F0"/>
+          </a:solidFill>
+          <a:ln>
+            <a:noFill/>
+          </a:ln>
+        </p:spPr>
+        <p:style>
+          <a:lnRef idx="1">
+            <a:schemeClr val="accent1"/>
+          </a:lnRef>
+          <a:fillRef idx="3">
+            <a:schemeClr val="accent1"/>
+          </a:fillRef>
+          <a:effectRef idx="2">
+            <a:schemeClr val="accent1"/>
+          </a:effectRef>
+          <a:fontRef idx="minor">
+            <a:schemeClr val="lt1"/>
+          </a:fontRef>
+        </p:style>
+        <p:txBody>
+          <a:bodyPr rtlCol="0" anchor="ctr"/>
+          <a:lstStyle/>
+          <a:p>
+            <a:pPr algn="ctr"/>
+          </a:p>
+        </p:txBody>
+      </p:sp>
+      <p:sp>
+        <p:nvSpPr>
+          <p:cNvPr id="32" name="Rectangle 31"/>
+          <p:cNvSpPr/>
+          <p:nvPr/>
+        </p:nvSpPr>
+        <p:spPr>
+          <a:xfrm>
+            <a:off x="450000" y="6575400"/>
+            <a:ext cx="64800" cy="342000"/>
+          </a:xfrm>
+          <a:prstGeom prst="rect">
+            <a:avLst/>
+          </a:prstGeom>
+          <a:solidFill>
+            <a:srgbClr val="FF1721"/>
+          </a:solidFill>
+          <a:ln>
+            <a:noFill/>
+          </a:ln>
+        </p:spPr>
+        <p:style>
+          <a:lnRef idx="1">
+            <a:schemeClr val="accent1"/>
+          </a:lnRef>
+          <a:fillRef idx="3">
+            <a:schemeClr val="accent1"/>
+          </a:fillRef>
+          <a:effectRef idx="2">
+            <a:schemeClr val="accent1"/>
+          </a:effectRef>
+          <a:fontRef idx="minor">
+            <a:schemeClr val="lt1"/>
+          </a:fontRef>
+        </p:style>
+        <p:txBody>
+          <a:bodyPr rtlCol="0" anchor="ctr"/>
+          <a:lstStyle/>
+          <a:p>
+            <a:pPr algn="ctr"/>
+          </a:p>
+        </p:txBody>
+      </p:sp>
+      <p:sp>
+        <p:nvSpPr>
+          <p:cNvPr id="33" name="TextBox 32"/>
+          <p:cNvSpPr txBox="1"/>
+          <p:nvPr/>
+        </p:nvSpPr>
+        <p:spPr>
+          <a:xfrm>
+            <a:off x="550800" y="6604200"/>
+            <a:ext cx="6534001" cy="291600"/>
+          </a:xfrm>
+          <a:prstGeom prst="rect">
+            <a:avLst/>
+          </a:prstGeom>
+          <a:noFill/>
+        </p:spPr>
+        <p:txBody>
+          <a:bodyPr wrap="square" lIns="18000" rIns="18000" tIns="0" bIns="0">
+            <a:spAutoFit/>
+          </a:bodyPr>
+          <a:lstStyle/>
+          <a:p>
+            <a:pPr algn="l">
+              <a:lnSpc>
+                <a:spcPct val="108000"/>
+              </a:lnSpc>
+            </a:pPr>
+            <a:r>
+              <a:rPr sz="850" b="1" i="0">
+                <a:solidFill>
+                  <a:srgbClr val="FF1721"/>
+                </a:solidFill>
+                <a:latin typeface="Arial"/>
+              </a:rPr>
+              <a:t>⚠  </a:t>
+            </a:r>
+            <a:r>
+              <a:rPr sz="850" b="0" i="0">
+                <a:solidFill>
+                  <a:srgbClr val="8F0000"/>
+                </a:solidFill>
+                <a:latin typeface="Arial"/>
+              </a:rPr>
+              <a:t>Alle Freigaben mit dem alten UPN werden </a:t>
+            </a:r>
+            <a:r>
+              <a:rPr sz="850" b="1" i="0">
+                <a:solidFill>
+                  <a:srgbClr val="8F0000"/>
+                </a:solidFill>
+                <a:latin typeface="Arial"/>
+              </a:rPr>
+              <a:t>automatisch ungültig.</a:t>
+            </a:r>
+            <a:r>
+              <a:rPr sz="850" b="0" i="0">
+                <a:solidFill>
+                  <a:srgbClr val="8F0000"/>
+                </a:solidFill>
+                <a:latin typeface="Arial"/>
+              </a:rPr>
+              <a:t> Empfänger verlieren den Zugriff — jedes Element muss manuell neu geteilt werden.</a:t>
+            </a:r>
+          </a:p>
+        </p:txBody>
+      </p:sp>
+      <p:sp>
+        <p:nvSpPr>
+          <p:cNvPr id="34" name="TextBox 33"/>
+          <p:cNvSpPr txBox="1"/>
+          <p:nvPr/>
+        </p:nvSpPr>
+        <p:spPr>
+          <a:xfrm>
+            <a:off x="450000" y="6982200"/>
+            <a:ext cx="259200" cy="1092600"/>
+          </a:xfrm>
+          <a:prstGeom prst="rect">
+            <a:avLst/>
+          </a:prstGeom>
+          <a:noFill/>
+        </p:spPr>
+        <p:txBody>
+          <a:bodyPr wrap="none" lIns="0" rIns="0" tIns="0" bIns="0">
+            <a:spAutoFit/>
+          </a:bodyPr>
+          <a:lstStyle/>
+          <a:p>
+            <a:pPr algn="ctr"/>
+            <a:r>
+              <a:rPr sz="1200" b="1" i="0">
+                <a:solidFill>
+                  <a:srgbClr val="00008F"/>
+                </a:solidFill>
+                <a:latin typeface="Arial"/>
+              </a:rPr>
+              <a:t>1</a:t>
+            </a:r>
+          </a:p>
+        </p:txBody>
+      </p:sp>
+      <p:sp>
+        <p:nvSpPr>
+          <p:cNvPr id="35" name="TextBox 34"/>
+          <p:cNvSpPr txBox="1"/>
+          <p:nvPr/>
+        </p:nvSpPr>
+        <p:spPr>
+          <a:xfrm>
+            <a:off x="752400" y="6967800"/>
+            <a:ext cx="6357600" cy="1092600"/>
+          </a:xfrm>
+          <a:prstGeom prst="rect">
+            <a:avLst/>
+          </a:prstGeom>
+          <a:noFill/>
+        </p:spPr>
+        <p:txBody>
+          <a:bodyPr wrap="square" lIns="0" rIns="0" tIns="0" bIns="0">
+            <a:spAutoFit/>
+          </a:bodyPr>
+          <a:lstStyle/>
+          <a:p>
+            <a:pPr algn="l">
+              <a:spcAft>
+                <a:spcPts val="100"/>
+              </a:spcAft>
+            </a:pPr>
+            <a:r>
+              <a:rPr sz="850" b="1" i="0">
+                <a:solidFill>
+                  <a:srgbClr val="343C3D"/>
+                </a:solidFill>
+                <a:latin typeface="Arial"/>
+              </a:rPr>
+              <a:t>Freigegebene Elemente finden</a:t>
+            </a:r>
+          </a:p>
+          <a:p>
+            <a:pPr algn="l">
+              <a:lnSpc>
+                <a:spcPct val="100000"/>
+              </a:lnSpc>
+            </a:pPr>
+            <a:r>
+              <a:rPr sz="780" b="0" i="0">
+                <a:solidFill>
+                  <a:srgbClr val="343C3D"/>
+                </a:solidFill>
+                <a:latin typeface="Arial"/>
+              </a:rPr>
+              <a:t>Bei onedrive.com mit neuer Adresse anmelden → im linken Bereich auf «Geteilt» klicken → alle früheren Freigaben werden angezeigt.</a:t>
+            </a:r>
+          </a:p>
+        </p:txBody>
+      </p:sp>
+      <p:sp>
+        <p:nvSpPr>
+          <p:cNvPr id="36" name="Rectangle 35"/>
+          <p:cNvSpPr/>
+          <p:nvPr/>
+        </p:nvSpPr>
+        <p:spPr>
+          <a:xfrm>
+            <a:off x="450000" y="8069400"/>
+            <a:ext cx="6642001" cy="4320"/>
+          </a:xfrm>
+          <a:prstGeom prst="rect">
+            <a:avLst/>
+          </a:prstGeom>
+          <a:solidFill>
+            <a:srgbClr val="BBBBE8"/>
+          </a:solidFill>
+          <a:ln>
+            <a:noFill/>
+          </a:ln>
+        </p:spPr>
+        <p:style>
+          <a:lnRef idx="1">
+            <a:schemeClr val="accent1"/>
+          </a:lnRef>
+          <a:fillRef idx="3">
+            <a:schemeClr val="accent1"/>
+          </a:fillRef>
+          <a:effectRef idx="2">
+            <a:schemeClr val="accent1"/>
+          </a:effectRef>
+          <a:fontRef idx="minor">
+            <a:schemeClr val="lt1"/>
+          </a:fontRef>
+        </p:style>
+        <p:txBody>
+          <a:bodyPr rtlCol="0" anchor="ctr"/>
+          <a:lstStyle/>
+          <a:p>
+            <a:pPr algn="ctr"/>
+          </a:p>
+        </p:txBody>
+      </p:sp>
+      <p:sp>
+        <p:nvSpPr>
+          <p:cNvPr id="37" name="TextBox 36"/>
+          <p:cNvSpPr txBox="1"/>
+          <p:nvPr/>
+        </p:nvSpPr>
+        <p:spPr>
+          <a:xfrm>
+            <a:off x="450000" y="8092800"/>
+            <a:ext cx="259200" cy="1092600"/>
+          </a:xfrm>
+          <a:prstGeom prst="rect">
+            <a:avLst/>
+          </a:prstGeom>
+          <a:noFill/>
+        </p:spPr>
+        <p:txBody>
+          <a:bodyPr wrap="none" lIns="0" rIns="0" tIns="0" bIns="0">
+            <a:spAutoFit/>
+          </a:bodyPr>
+          <a:lstStyle/>
+          <a:p>
+            <a:pPr algn="ctr"/>
+            <a:r>
+              <a:rPr sz="1200" b="1" i="0">
+                <a:solidFill>
+                  <a:srgbClr val="00008F"/>
+                </a:solidFill>
+                <a:latin typeface="Arial"/>
+              </a:rPr>
+              <a:t>2</a:t>
+            </a:r>
+          </a:p>
+        </p:txBody>
+      </p:sp>
+      <p:sp>
+        <p:nvSpPr>
+          <p:cNvPr id="38" name="TextBox 37"/>
+          <p:cNvSpPr txBox="1"/>
+          <p:nvPr/>
+        </p:nvSpPr>
+        <p:spPr>
+          <a:xfrm>
+            <a:off x="752400" y="8078400"/>
+            <a:ext cx="6357600" cy="1092600"/>
+          </a:xfrm>
+          <a:prstGeom prst="rect">
+            <a:avLst/>
+          </a:prstGeom>
+          <a:noFill/>
+        </p:spPr>
+        <p:txBody>
+          <a:bodyPr wrap="square" lIns="0" rIns="0" tIns="0" bIns="0">
+            <a:spAutoFit/>
+          </a:bodyPr>
+          <a:lstStyle/>
+          <a:p>
+            <a:pPr algn="l">
+              <a:spcAft>
+                <a:spcPts val="100"/>
+              </a:spcAft>
+            </a:pPr>
+            <a:r>
+              <a:rPr sz="850" b="1" i="0">
+                <a:solidFill>
+                  <a:srgbClr val="343C3D"/>
+                </a:solidFill>
+                <a:latin typeface="Arial"/>
+              </a:rPr>
+              <a:t>Jede Datei / jeden Ordner neu freigeben</a:t>
+            </a:r>
+          </a:p>
+          <a:p>
+            <a:pPr algn="l">
+              <a:lnSpc>
+                <a:spcPct val="100000"/>
+              </a:lnSpc>
+            </a:pPr>
+            <a:r>
+              <a:rPr sz="780" b="0" i="0">
+                <a:solidFill>
+                  <a:srgbClr val="343C3D"/>
+                </a:solidFill>
+                <a:latin typeface="Arial"/>
+              </a:rPr>
+              <a:t>Rechtsklick → Freigeben → Empfänger eingeben → Berechtigung wählen (Anzeigen / Bearbeiten) → Senden.</a:t>
+            </a:r>
+          </a:p>
+        </p:txBody>
+      </p:sp>
+      <p:sp>
+        <p:nvSpPr>
+          <p:cNvPr id="39" name="Rectangle 38"/>
+          <p:cNvSpPr/>
+          <p:nvPr/>
+        </p:nvSpPr>
+        <p:spPr>
+          <a:xfrm>
+            <a:off x="450000" y="9180000"/>
+            <a:ext cx="6642001" cy="4320"/>
+          </a:xfrm>
+          <a:prstGeom prst="rect">
+            <a:avLst/>
+          </a:prstGeom>
+          <a:solidFill>
+            <a:srgbClr val="BBBBE8"/>
+          </a:solidFill>
+          <a:ln>
+            <a:noFill/>
+          </a:ln>
+        </p:spPr>
+        <p:style>
+          <a:lnRef idx="1">
+            <a:schemeClr val="accent1"/>
+          </a:lnRef>
+          <a:fillRef idx="3">
+            <a:schemeClr val="accent1"/>
+          </a:fillRef>
+          <a:effectRef idx="2">
+            <a:schemeClr val="accent1"/>
+          </a:effectRef>
+          <a:fontRef idx="minor">
+            <a:schemeClr val="lt1"/>
+          </a:fontRef>
+        </p:style>
+        <p:txBody>
+          <a:bodyPr rtlCol="0" anchor="ctr"/>
+          <a:lstStyle/>
+          <a:p>
+            <a:pPr algn="ctr"/>
+          </a:p>
+        </p:txBody>
+      </p:sp>
+      <p:sp>
+        <p:nvSpPr>
+          <p:cNvPr id="40" name="TextBox 39"/>
+          <p:cNvSpPr txBox="1"/>
+          <p:nvPr/>
+        </p:nvSpPr>
+        <p:spPr>
+          <a:xfrm>
+            <a:off x="450000" y="9203400"/>
+            <a:ext cx="259200" cy="1092600"/>
+          </a:xfrm>
+          <a:prstGeom prst="rect">
+            <a:avLst/>
+          </a:prstGeom>
+          <a:noFill/>
+        </p:spPr>
+        <p:txBody>
+          <a:bodyPr wrap="none" lIns="0" rIns="0" tIns="0" bIns="0">
+            <a:spAutoFit/>
+          </a:bodyPr>
+          <a:lstStyle/>
+          <a:p>
+            <a:pPr algn="ctr"/>
+            <a:r>
+              <a:rPr sz="1200" b="1" i="0">
+                <a:solidFill>
+                  <a:srgbClr val="00008F"/>
+                </a:solidFill>
+                <a:latin typeface="Arial"/>
+              </a:rPr>
+              <a:t>3</a:t>
+            </a:r>
+          </a:p>
+        </p:txBody>
+      </p:sp>
+      <p:sp>
+        <p:nvSpPr>
+          <p:cNvPr id="41" name="TextBox 40"/>
+          <p:cNvSpPr txBox="1"/>
+          <p:nvPr/>
+        </p:nvSpPr>
+        <p:spPr>
+          <a:xfrm>
+            <a:off x="752400" y="9189000"/>
+            <a:ext cx="6357600" cy="1092600"/>
+          </a:xfrm>
+          <a:prstGeom prst="rect">
+            <a:avLst/>
+          </a:prstGeom>
+          <a:noFill/>
+        </p:spPr>
+        <p:txBody>
+          <a:bodyPr wrap="square" lIns="0" rIns="0" tIns="0" bIns="0">
+            <a:spAutoFit/>
+          </a:bodyPr>
+          <a:lstStyle/>
+          <a:p>
+            <a:pPr algn="l">
+              <a:spcAft>
+                <a:spcPts val="100"/>
+              </a:spcAft>
+            </a:pPr>
+            <a:r>
+              <a:rPr sz="850" b="1" i="0">
+                <a:solidFill>
+                  <a:srgbClr val="343C3D"/>
+                </a:solidFill>
+                <a:latin typeface="Arial"/>
+              </a:rPr>
+              <a:t>Empfänger über neuen Link informieren</a:t>
+            </a:r>
+          </a:p>
+          <a:p>
+            <a:pPr algn="l">
+              <a:lnSpc>
+                <a:spcPct val="100000"/>
+              </a:lnSpc>
+            </a:pPr>
+            <a:r>
+              <a:rPr sz="780" b="0" i="0">
+                <a:solidFill>
+                  <a:srgbClr val="343C3D"/>
+                </a:solidFill>
+                <a:latin typeface="Arial"/>
+              </a:rPr>
+              <a:t>Alte Links funktionieren nicht mehr. Neue Einladung versenden oder Link direkt mitteilen. Für SharePoint-Bibliotheken das IT-Team kontaktieren.</a:t>
+            </a:r>
+          </a:p>
+        </p:txBody>
+      </p:sp>
+      <p:sp>
+        <p:nvSpPr>
+          <p:cNvPr id="42" name="Rectangle 41"/>
+          <p:cNvSpPr/>
+          <p:nvPr/>
+        </p:nvSpPr>
+        <p:spPr>
+          <a:xfrm>
+            <a:off x="396000" y="10371600"/>
+            <a:ext cx="6768000" cy="9000"/>
+          </a:xfrm>
+          <a:prstGeom prst="rect">
+            <a:avLst/>
+          </a:prstGeom>
+          <a:solidFill>
+            <a:srgbClr val="CCCCCC"/>
+          </a:solidFill>
+          <a:ln>
+            <a:noFill/>
+          </a:ln>
+        </p:spPr>
+        <p:style>
+          <a:lnRef idx="1">
+            <a:schemeClr val="accent1"/>
+          </a:lnRef>
+          <a:fillRef idx="3">
+            <a:schemeClr val="accent1"/>
+          </a:fillRef>
+          <a:effectRef idx="2">
+            <a:schemeClr val="accent1"/>
+          </a:effectRef>
+          <a:fontRef idx="minor">
+            <a:schemeClr val="lt1"/>
+          </a:fontRef>
+        </p:style>
+        <p:txBody>
+          <a:bodyPr rtlCol="0" anchor="ctr"/>
+          <a:lstStyle/>
+          <a:p>
+            <a:pPr algn="ctr"/>
+          </a:p>
+        </p:txBody>
+      </p:sp>
+      <p:sp>
+        <p:nvSpPr>
+          <p:cNvPr id="43" name="TextBox 42"/>
+          <p:cNvSpPr txBox="1"/>
+          <p:nvPr/>
+        </p:nvSpPr>
+        <p:spPr>
+          <a:xfrm>
+            <a:off x="396000" y="10393200"/>
+            <a:ext cx="6768000" cy="212400"/>
+          </a:xfrm>
+          <a:prstGeom prst="rect">
+            <a:avLst/>
+          </a:prstGeom>
+          <a:noFill/>
+        </p:spPr>
+        <p:txBody>
+          <a:bodyPr wrap="square" lIns="0" rIns="0" tIns="0" bIns="0">
             <a:spAutoFit/>
           </a:bodyPr>
           <a:lstStyle/>

</xml_diff>